<commit_message>
Fix four cross-references found by the learning-status audit
- Lecture 02, slide 11 note and Chapter 2: the stack is treated in
  Lecture/Chapter 18, not "in the lectures on memory and on subroutines"
- Lecture 22, slide 3, its note and Chapter 22: divu/remu come from
  Lectures 05 and 06, not Lecture 18
- Lecture 07, slide 24 note and Chapter 7: Lecture 19 explains the
  formats; compressed forms are only named there and listed in Appendix A
- Lecture 18, slide 16 (caption, note) and Chapter 18: state the
  caller-saved / callee-saved rule of the calling convention

Both languages; review flags removed from the registry; decks, notes,
PDFs and zips regenerated.

Co-Authored-By: Claude Opus 5.5 <noreply@anthropic.com>
</commit_message>
<xml_diff>
--- a/en/slides/00-Computer_Architecture-Course_Introduction-Code.pptx
+++ b/en/slides/00-Computer_Architecture-Course_Introduction-Code.pptx
@@ -116,24 +116,24 @@
   <p:extLst>
     <p:ext uri="{521415D9-36F7-43E2-AB2F-B90AF26B5E84}">
       <p14:sectionLst xmlns:p14="http://schemas.microsoft.com/office/powerpoint/2010/main">
-        <p14:section name="Opening" id="{36258862-6859-27cd-fd8e-3551376115ab}">
+        <p14:section name="Opening" id="{1cd98b2a-dc7d-dd9f-e247-12715879c3e2}">
           <p14:sldIdLst>
             <p14:sldId id="256"/>
             <p14:sldId id="257"/>
           </p14:sldIdLst>
         </p14:section>
-        <p14:section name="Material and first contact" id="{d11b5065-2150-1e9b-b19d-09b591d6e888}">
+        <p14:section name="Material and first contact" id="{2fa7a465-d88f-8a1b-b01e-13c3cfc24208}">
           <p14:sldIdLst>
             <p14:sldId id="258"/>
           </p14:sldIdLst>
         </p14:section>
-        <p14:section name="The complete program" id="{d3c1d01e-1a36-eafb-2021-5732982d0a86}">
+        <p14:section name="The complete program" id="{cc2b4746-892c-9476-8918-fecb9a7d4978}">
           <p14:sldIdLst>
             <p14:sldId id="259"/>
             <p14:sldId id="260"/>
           </p14:sldIdLst>
         </p14:section>
-        <p14:section name="Run it and test it" id="{80a4b8a9-d3f9-1223-64a5-3e9b87790bd6}">
+        <p14:section name="Run it and test it" id="{ac354c50-1665-fda6-c7e2-d8dc25673172}">
           <p14:sldIdLst>
             <p14:sldId id="261"/>
             <p14:sldId id="262"/>

</xml_diff>